<commit_message>
refactor: change UI colors
</commit_message>
<xml_diff>
--- a/Caso-Practico-WhereX-Francisco-Pieper.pptx
+++ b/Caso-Practico-WhereX-Francisco-Pieper.pptx
@@ -5839,7 +5839,7 @@
                 <a:ea typeface="Calibri" pitchFamily="34" charset="-122"/>
                 <a:cs typeface="Calibri" pitchFamily="34" charset="-120"/>
               </a:rPr>
-              <a:t>Equipos citados a dos partidos a la vez</a:t>
+              <a:t>Ignora por completo de quién es la cancha</a:t>
             </a:r>
             <a:endParaRPr lang="en-US" sz="1450" dirty="0"/>
           </a:p>
@@ -5879,7 +5879,7 @@
                 <a:ea typeface="Calibri" pitchFamily="34" charset="-122"/>
                 <a:cs typeface="Calibri" pitchFamily="34" charset="-120"/>
               </a:rPr>
-              <a:t>Árbitros duplicados en el mismo horario</a:t>
+              <a:t>La mayoría de los partidos en la cancha equivocada</a:t>
             </a:r>
             <a:endParaRPr lang="en-US" sz="1450" dirty="0"/>
           </a:p>
@@ -5919,7 +5919,7 @@
                 <a:ea typeface="Calibri" pitchFamily="34" charset="-122"/>
                 <a:cs typeface="Calibri" pitchFamily="34" charset="-120"/>
               </a:rPr>
-              <a:t>Partidos en recintos que no son de nadie</a:t>
+              <a:t>Varones agendados en canchas de colegio</a:t>
             </a:r>
             <a:endParaRPr lang="en-US" sz="1450" dirty="0"/>
           </a:p>
@@ -5959,7 +5959,7 @@
                 <a:ea typeface="Calibri" pitchFamily="34" charset="-122"/>
                 <a:cs typeface="Calibri" pitchFamily="34" charset="-120"/>
               </a:rPr>
-              <a:t>Todo apretado en el mismo día</a:t>
+              <a:t>Los mismos equipos siempre en los peores horarios</a:t>
             </a:r>
             <a:endParaRPr lang="en-US" sz="1450" dirty="0"/>
           </a:p>
@@ -6124,7 +6124,7 @@
                 <a:ea typeface="Calibri" pitchFamily="34" charset="-122"/>
                 <a:cs typeface="Calibri" pitchFamily="34" charset="-120"/>
               </a:rPr>
-              <a:t>184 de 184 partidos agendados</a:t>
+              <a:t>520 de 520 partidos agendados</a:t>
             </a:r>
             <a:endParaRPr lang="en-US" sz="1450" dirty="0"/>
           </a:p>
@@ -6204,7 +6204,7 @@
                 <a:ea typeface="Calibri" pitchFamily="34" charset="-122"/>
                 <a:cs typeface="Calibri" pitchFamily="34" charset="-120"/>
               </a:rPr>
-              <a:t>100% en horarios razonables</a:t>
+              <a:t>95% en horarios razonables</a:t>
             </a:r>
             <a:endParaRPr lang="en-US" sz="1450" dirty="0"/>
           </a:p>
@@ -6283,7 +6283,7 @@
                 <a:ea typeface="Calibri" pitchFamily="34" charset="-122"/>
                 <a:cs typeface="Calibri" pitchFamily="34" charset="-120"/>
               </a:rPr>
-              <a:t>Verificado con 32 tests automatizados.</a:t>
+              <a:t>Verificado con 31 tests automatizados.</a:t>
             </a:r>
             <a:endParaRPr lang="en-US" sz="1350" dirty="0"/>
           </a:p>
@@ -8037,7 +8037,7 @@
                 <a:ea typeface="Calibri" pitchFamily="34" charset="-122"/>
                 <a:cs typeface="Calibri" pitchFamily="34" charset="-120"/>
               </a:rPr>
-              <a:t>El problema cabe en memoria: el semestre completo se resuelve en 180 milisegundos. Separar servicios sería complejidad sin problema que la justifique.</a:t>
+              <a:t>El problema cabe en memoria: el semestre completo se resuelve en poco más de un segundo. Separar servicios sería complejidad sin problema que la justifique.</a:t>
             </a:r>
             <a:endParaRPr lang="en-US" sz="1400" dirty="0"/>
           </a:p>

</xml_diff>